<commit_message>
Refine Knowdit flowchart layout and text color
Co-authored-by: Zhou Jinming <reconf-fly@users.noreply.github.com>
</commit_message>
<xml_diff>
--- a/knowdit框架流程图.pptx
+++ b/knowdit框架流程图.pptx
@@ -3104,6 +3104,13 @@
           <a:bodyPr/>
           <a:lstStyle/>
           <a:p>
+            <a:pPr>
+              <a:defRPr>
+                <a:solidFill>
+                  <a:srgbClr val="000000"/>
+                </a:solidFill>
+              </a:defRPr>
+            </a:pPr>
             <a:r>
               <a:t>Knowdit 框架流程图</a:t>
             </a:r>
@@ -3125,13 +3132,15 @@
           <a:bodyPr/>
           <a:lstStyle/>
           <a:p>
-            <a:r>
-              <a:t>基于论文：Knowdit: Agentic Smart Contract Vulnerability Detection</a:t>
-            </a:r>
-          </a:p>
-          <a:p>
-            <a:r>
-              <a:t>with Auditing Knowledge Summarization</a:t>
+            <a:pPr>
+              <a:defRPr>
+                <a:solidFill>
+                  <a:srgbClr val="000000"/>
+                </a:solidFill>
+              </a:defRPr>
+            </a:pPr>
+            <a:r>
+              <a:t>重新整理版：清晰单向箭头 + 黑色文字</a:t>
             </a:r>
           </a:p>
         </p:txBody>
@@ -3163,7 +3172,7 @@
         <p:spPr>
           <a:xfrm>
             <a:off x="274320" y="91440"/>
-            <a:ext cx="11612880" cy="457200"/>
+            <a:ext cx="11521440" cy="411480"/>
           </a:xfrm>
           <a:prstGeom prst="rect">
             <a:avLst/>
@@ -3177,14 +3186,14 @@
           <a:lstStyle/>
           <a:p>
             <a:pPr>
-              <a:defRPr sz="2400" b="1">
+              <a:defRPr sz="2200" b="1">
                 <a:solidFill>
-                  <a:srgbClr val="1E1E1E"/>
+                  <a:srgbClr val="000000"/>
                 </a:solidFill>
               </a:defRPr>
             </a:pPr>
             <a:r>
-              <a:t>Knowdit 总体流程：知识图谱构建 + Agentic 漏洞审计闭环</a:t>
+              <a:t>Knowdit：知识图谱驱动的 Agentic 漏洞检测流程</a:t>
             </a:r>
           </a:p>
         </p:txBody>
@@ -3197,15 +3206,20 @@
         </p:nvSpPr>
         <p:spPr>
           <a:xfrm>
-            <a:off x="274320" y="822960"/>
-            <a:ext cx="1828800" cy="731520"/>
+            <a:off x="365760" y="822960"/>
+            <a:ext cx="1737360" cy="731520"/>
           </a:xfrm>
           <a:prstGeom prst="roundRect">
             <a:avLst/>
           </a:prstGeom>
           <a:solidFill>
-            <a:srgbClr val="E6F2FF"/>
+            <a:srgbClr val="DEEBF7"/>
           </a:solidFill>
+          <a:ln w="15875">
+            <a:solidFill>
+              <a:srgbClr val="464646"/>
+            </a:solidFill>
+          </a:ln>
         </p:spPr>
         <p:style>
           <a:lnRef idx="1">
@@ -3225,27 +3239,19 @@
           <a:bodyPr rtlCol="0" anchor="ctr"/>
           <a:lstStyle/>
           <a:p>
-            <a:pPr>
-              <a:defRPr sz="1100"/>
+            <a:pPr algn="ctr">
+              <a:defRPr sz="1300">
+                <a:solidFill>
+                  <a:srgbClr val="000000"/>
+                </a:solidFill>
+              </a:defRPr>
             </a:pPr>
             <a:r>
-              <a:t>输入数据</a:t>
-            </a:r>
-          </a:p>
-          <a:p>
-            <a:pPr>
-              <a:defRPr sz="1100"/>
-            </a:pPr>
-            <a:r>
-              <a:t>历史项目代码</a:t>
-            </a:r>
-          </a:p>
-          <a:p>
-            <a:pPr>
-              <a:defRPr sz="1100"/>
-            </a:pPr>
-            <a:r>
-              <a:t>+ 审计报告</a:t>
+              <a:t>输入</a:t>
+            </a:r>
+            <a:br/>
+            <a:r>
+              <a:t>历史项目+审计报告</a:t>
             </a:r>
           </a:p>
         </p:txBody>
@@ -3258,15 +3264,20 @@
         </p:nvSpPr>
         <p:spPr>
           <a:xfrm>
-            <a:off x="2377440" y="731520"/>
-            <a:ext cx="1920240" cy="731520"/>
+            <a:off x="2377440" y="822960"/>
+            <a:ext cx="1828800" cy="731520"/>
           </a:xfrm>
           <a:prstGeom prst="roundRect">
             <a:avLst/>
           </a:prstGeom>
           <a:solidFill>
-            <a:srgbClr val="DCEDC8"/>
+            <a:srgbClr val="E2EFDA"/>
           </a:solidFill>
+          <a:ln w="15875">
+            <a:solidFill>
+              <a:srgbClr val="464646"/>
+            </a:solidFill>
+          </a:ln>
         </p:spPr>
         <p:style>
           <a:lnRef idx="1">
@@ -3286,19 +3297,19 @@
           <a:bodyPr rtlCol="0" anchor="ctr"/>
           <a:lstStyle/>
           <a:p>
-            <a:pPr>
-              <a:defRPr sz="1100"/>
+            <a:pPr algn="ctr">
+              <a:defRPr sz="1300">
+                <a:solidFill>
+                  <a:srgbClr val="000000"/>
+                </a:solidFill>
+              </a:defRPr>
             </a:pPr>
             <a:r>
-              <a:t>阶段 I</a:t>
-            </a:r>
-          </a:p>
-          <a:p>
-            <a:pPr>
-              <a:defRPr sz="1100"/>
-            </a:pPr>
-            <a:r>
-              <a:t>DeFi 语义提取/去重</a:t>
+              <a:t>阶段I</a:t>
+            </a:r>
+            <a:br/>
+            <a:r>
+              <a:t>DeFi语义提取/去重</a:t>
             </a:r>
           </a:p>
         </p:txBody>
@@ -3311,15 +3322,20 @@
         </p:nvSpPr>
         <p:spPr>
           <a:xfrm>
-            <a:off x="2377440" y="1645920"/>
-            <a:ext cx="1920240" cy="731520"/>
+            <a:off x="4480560" y="822960"/>
+            <a:ext cx="1828800" cy="731520"/>
           </a:xfrm>
           <a:prstGeom prst="roundRect">
             <a:avLst/>
           </a:prstGeom>
           <a:solidFill>
-            <a:srgbClr val="DCEDC8"/>
+            <a:srgbClr val="E2EFDA"/>
           </a:solidFill>
+          <a:ln w="15875">
+            <a:solidFill>
+              <a:srgbClr val="464646"/>
+            </a:solidFill>
+          </a:ln>
         </p:spPr>
         <p:style>
           <a:lnRef idx="1">
@@ -3339,17 +3355,17 @@
           <a:bodyPr rtlCol="0" anchor="ctr"/>
           <a:lstStyle/>
           <a:p>
-            <a:pPr>
-              <a:defRPr sz="1100"/>
+            <a:pPr algn="ctr">
+              <a:defRPr sz="1300">
+                <a:solidFill>
+                  <a:srgbClr val="000000"/>
+                </a:solidFill>
+              </a:defRPr>
             </a:pPr>
             <a:r>
-              <a:t>阶段 II</a:t>
-            </a:r>
-          </a:p>
-          <a:p>
-            <a:pPr>
-              <a:defRPr sz="1100"/>
-            </a:pPr>
+              <a:t>阶段II</a:t>
+            </a:r>
+            <a:br/>
             <a:r>
               <a:t>漏洞模式提取/去重</a:t>
             </a:r>
@@ -3364,15 +3380,20 @@
         </p:nvSpPr>
         <p:spPr>
           <a:xfrm>
-            <a:off x="2377440" y="2560320"/>
-            <a:ext cx="1920240" cy="731520"/>
+            <a:off x="6583680" y="822960"/>
+            <a:ext cx="1828800" cy="731520"/>
           </a:xfrm>
           <a:prstGeom prst="roundRect">
             <a:avLst/>
           </a:prstGeom>
           <a:solidFill>
-            <a:srgbClr val="DCEDC8"/>
+            <a:srgbClr val="E2EFDA"/>
           </a:solidFill>
+          <a:ln w="15875">
+            <a:solidFill>
+              <a:srgbClr val="464646"/>
+            </a:solidFill>
+          </a:ln>
         </p:spPr>
         <p:style>
           <a:lnRef idx="1">
@@ -3392,17 +3413,17 @@
           <a:bodyPr rtlCol="0" anchor="ctr"/>
           <a:lstStyle/>
           <a:p>
-            <a:pPr>
-              <a:defRPr sz="1100"/>
+            <a:pPr algn="ctr">
+              <a:defRPr sz="1300">
+                <a:solidFill>
+                  <a:srgbClr val="000000"/>
+                </a:solidFill>
+              </a:defRPr>
             </a:pPr>
             <a:r>
-              <a:t>阶段 III</a:t>
-            </a:r>
-          </a:p>
-          <a:p>
-            <a:pPr>
-              <a:defRPr sz="1100"/>
-            </a:pPr>
+              <a:t>阶段III</a:t>
+            </a:r>
+            <a:br/>
             <a:r>
               <a:t>语义-模式因果链接</a:t>
             </a:r>
@@ -3417,8 +3438,8 @@
         </p:nvSpPr>
         <p:spPr>
           <a:xfrm>
-            <a:off x="4572000" y="1463040"/>
-            <a:ext cx="1828800" cy="1097280"/>
+            <a:off x="8686800" y="822960"/>
+            <a:ext cx="2560320" cy="731520"/>
           </a:xfrm>
           <a:prstGeom prst="roundRect">
             <a:avLst/>
@@ -3426,6 +3447,11 @@
           <a:solidFill>
             <a:srgbClr val="FFF2CC"/>
           </a:solidFill>
+          <a:ln w="15875">
+            <a:solidFill>
+              <a:srgbClr val="464646"/>
+            </a:solidFill>
+          </a:ln>
         </p:spPr>
         <p:style>
           <a:lnRef idx="1">
@@ -3445,27 +3471,19 @@
           <a:bodyPr rtlCol="0" anchor="ctr"/>
           <a:lstStyle/>
           <a:p>
-            <a:pPr>
-              <a:defRPr sz="1100"/>
+            <a:pPr algn="ctr">
+              <a:defRPr sz="1300">
+                <a:solidFill>
+                  <a:srgbClr val="000000"/>
+                </a:solidFill>
+              </a:defRPr>
             </a:pPr>
             <a:r>
               <a:t>审计知识图谱 G</a:t>
             </a:r>
-          </a:p>
-          <a:p>
-            <a:pPr>
-              <a:defRPr sz="1100"/>
-            </a:pPr>
-            <a:r>
-              <a:t>DeFi Space +</a:t>
-            </a:r>
-          </a:p>
-          <a:p>
-            <a:pPr>
-              <a:defRPr sz="1100"/>
-            </a:pPr>
-            <a:r>
-              <a:t>Vulnerability Space</a:t>
+            <a:br/>
+            <a:r>
+              <a:t>DeFi Space + Vulnerability Space</a:t>
             </a:r>
           </a:p>
         </p:txBody>
@@ -3478,15 +3496,20 @@
         </p:nvSpPr>
         <p:spPr>
           <a:xfrm>
-            <a:off x="6675120" y="822960"/>
-            <a:ext cx="1554480" cy="640080"/>
+            <a:off x="365760" y="2148840"/>
+            <a:ext cx="1737360" cy="731520"/>
           </a:xfrm>
           <a:prstGeom prst="roundRect">
             <a:avLst/>
           </a:prstGeom>
           <a:solidFill>
-            <a:srgbClr val="E6F2FF"/>
+            <a:srgbClr val="DEEBF7"/>
           </a:solidFill>
+          <a:ln w="15875">
+            <a:solidFill>
+              <a:srgbClr val="464646"/>
+            </a:solidFill>
+          </a:ln>
         </p:spPr>
         <p:style>
           <a:lnRef idx="1">
@@ -3506,19 +3529,19 @@
           <a:bodyPr rtlCol="0" anchor="ctr"/>
           <a:lstStyle/>
           <a:p>
-            <a:pPr>
-              <a:defRPr sz="1100"/>
+            <a:pPr algn="ctr">
+              <a:defRPr sz="1300">
+                <a:solidFill>
+                  <a:srgbClr val="000000"/>
+                </a:solidFill>
+              </a:defRPr>
             </a:pPr>
             <a:r>
-              <a:t>新项目</a:t>
-            </a:r>
-          </a:p>
-          <a:p>
-            <a:pPr>
-              <a:defRPr sz="1100"/>
-            </a:pPr>
-            <a:r>
-              <a:t>Solidity</a:t>
+              <a:t>输入</a:t>
+            </a:r>
+            <a:br/>
+            <a:r>
+              <a:t>新项目 Solidity</a:t>
             </a:r>
           </a:p>
         </p:txBody>
@@ -3531,8 +3554,8 @@
         </p:nvSpPr>
         <p:spPr>
           <a:xfrm>
-            <a:off x="8412480" y="822960"/>
-            <a:ext cx="1737360" cy="640080"/>
+            <a:off x="2377440" y="2148840"/>
+            <a:ext cx="1828800" cy="731520"/>
           </a:xfrm>
           <a:prstGeom prst="roundRect">
             <a:avLst/>
@@ -3540,6 +3563,11 @@
           <a:solidFill>
             <a:srgbClr val="FFF2CC"/>
           </a:solidFill>
+          <a:ln w="15875">
+            <a:solidFill>
+              <a:srgbClr val="464646"/>
+            </a:solidFill>
+          </a:ln>
         </p:spPr>
         <p:style>
           <a:lnRef idx="1">
@@ -3559,19 +3587,19 @@
           <a:bodyPr rtlCol="0" anchor="ctr"/>
           <a:lstStyle/>
           <a:p>
-            <a:pPr>
-              <a:defRPr sz="1100"/>
+            <a:pPr algn="ctr">
+              <a:defRPr sz="1300">
+                <a:solidFill>
+                  <a:srgbClr val="000000"/>
+                </a:solidFill>
+              </a:defRPr>
             </a:pPr>
             <a:r>
-              <a:t>Knowledge</a:t>
-            </a:r>
-          </a:p>
-          <a:p>
-            <a:pPr>
-              <a:defRPr sz="1100"/>
-            </a:pPr>
-            <a:r>
-              <a:t>Mapper</a:t>
+              <a:t>1) Knowledge Mapper</a:t>
+            </a:r>
+            <a:br/>
+            <a:r>
+              <a:t>检索语义-漏洞对</a:t>
             </a:r>
           </a:p>
         </p:txBody>
@@ -3584,8 +3612,8 @@
         </p:nvSpPr>
         <p:spPr>
           <a:xfrm>
-            <a:off x="6675120" y="1828800"/>
-            <a:ext cx="1554480" cy="640080"/>
+            <a:off x="4480560" y="2148840"/>
+            <a:ext cx="1828800" cy="731520"/>
           </a:xfrm>
           <a:prstGeom prst="roundRect">
             <a:avLst/>
@@ -3593,6 +3621,11 @@
           <a:solidFill>
             <a:srgbClr val="FFF2CC"/>
           </a:solidFill>
+          <a:ln w="15875">
+            <a:solidFill>
+              <a:srgbClr val="464646"/>
+            </a:solidFill>
+          </a:ln>
         </p:spPr>
         <p:style>
           <a:lnRef idx="1">
@@ -3612,19 +3645,19 @@
           <a:bodyPr rtlCol="0" anchor="ctr"/>
           <a:lstStyle/>
           <a:p>
-            <a:pPr>
-              <a:defRPr sz="1100"/>
+            <a:pPr algn="ctr">
+              <a:defRPr sz="1300">
+                <a:solidFill>
+                  <a:srgbClr val="000000"/>
+                </a:solidFill>
+              </a:defRPr>
             </a:pPr>
             <a:r>
-              <a:t>Specification</a:t>
-            </a:r>
-          </a:p>
-          <a:p>
-            <a:pPr>
-              <a:defRPr sz="1100"/>
-            </a:pPr>
-            <a:r>
-              <a:t>Generator</a:t>
+              <a:t>2) Specification Generator</a:t>
+            </a:r>
+            <a:br/>
+            <a:r>
+              <a:t>生成审计规范</a:t>
             </a:r>
           </a:p>
         </p:txBody>
@@ -3637,8 +3670,8 @@
         </p:nvSpPr>
         <p:spPr>
           <a:xfrm>
-            <a:off x="8412480" y="1828800"/>
-            <a:ext cx="1737360" cy="640080"/>
+            <a:off x="6583680" y="2148840"/>
+            <a:ext cx="1828800" cy="731520"/>
           </a:xfrm>
           <a:prstGeom prst="roundRect">
             <a:avLst/>
@@ -3646,6 +3679,11 @@
           <a:solidFill>
             <a:srgbClr val="FFF2CC"/>
           </a:solidFill>
+          <a:ln w="15875">
+            <a:solidFill>
+              <a:srgbClr val="464646"/>
+            </a:solidFill>
+          </a:ln>
         </p:spPr>
         <p:style>
           <a:lnRef idx="1">
@@ -3665,19 +3703,19 @@
           <a:bodyPr rtlCol="0" anchor="ctr"/>
           <a:lstStyle/>
           <a:p>
-            <a:pPr>
-              <a:defRPr sz="1100"/>
+            <a:pPr algn="ctr">
+              <a:defRPr sz="1300">
+                <a:solidFill>
+                  <a:srgbClr val="000000"/>
+                </a:solidFill>
+              </a:defRPr>
             </a:pPr>
             <a:r>
-              <a:t>Harness</a:t>
-            </a:r>
-          </a:p>
-          <a:p>
-            <a:pPr>
-              <a:defRPr sz="1100"/>
-            </a:pPr>
-            <a:r>
-              <a:t>Synthesizer</a:t>
+              <a:t>3) Harness Synthesizer</a:t>
+            </a:r>
+            <a:br/>
+            <a:r>
+              <a:t>生成/修复测试Harness</a:t>
             </a:r>
           </a:p>
         </p:txBody>
@@ -3690,8 +3728,8 @@
         </p:nvSpPr>
         <p:spPr>
           <a:xfrm>
-            <a:off x="6675120" y="2834640"/>
-            <a:ext cx="1554480" cy="640080"/>
+            <a:off x="8686800" y="2148840"/>
+            <a:ext cx="1188720" cy="731520"/>
           </a:xfrm>
           <a:prstGeom prst="roundRect">
             <a:avLst/>
@@ -3699,6 +3737,11 @@
           <a:solidFill>
             <a:srgbClr val="FFF2CC"/>
           </a:solidFill>
+          <a:ln w="15875">
+            <a:solidFill>
+              <a:srgbClr val="464646"/>
+            </a:solidFill>
+          </a:ln>
         </p:spPr>
         <p:style>
           <a:lnRef idx="1">
@@ -3718,17 +3761,17 @@
           <a:bodyPr rtlCol="0" anchor="ctr"/>
           <a:lstStyle/>
           <a:p>
-            <a:pPr>
-              <a:defRPr sz="1100"/>
+            <a:pPr algn="ctr">
+              <a:defRPr sz="1300">
+                <a:solidFill>
+                  <a:srgbClr val="000000"/>
+                </a:solidFill>
+              </a:defRPr>
             </a:pPr>
             <a:r>
-              <a:t>Fuzz</a:t>
-            </a:r>
-          </a:p>
-          <a:p>
-            <a:pPr>
-              <a:defRPr sz="1100"/>
-            </a:pPr>
+              <a:t>4) Fuzz</a:t>
+            </a:r>
+            <a:br/>
             <a:r>
               <a:t>Executor</a:t>
             </a:r>
@@ -3743,8 +3786,8 @@
         </p:nvSpPr>
         <p:spPr>
           <a:xfrm>
-            <a:off x="8412480" y="2834640"/>
-            <a:ext cx="1737360" cy="640080"/>
+            <a:off x="10149840" y="2148840"/>
+            <a:ext cx="1097280" cy="731520"/>
           </a:xfrm>
           <a:prstGeom prst="roundRect">
             <a:avLst/>
@@ -3752,6 +3795,11 @@
           <a:solidFill>
             <a:srgbClr val="FFF2CC"/>
           </a:solidFill>
+          <a:ln w="15875">
+            <a:solidFill>
+              <a:srgbClr val="464646"/>
+            </a:solidFill>
+          </a:ln>
         </p:spPr>
         <p:style>
           <a:lnRef idx="1">
@@ -3771,17 +3819,17 @@
           <a:bodyPr rtlCol="0" anchor="ctr"/>
           <a:lstStyle/>
           <a:p>
-            <a:pPr>
-              <a:defRPr sz="1100"/>
+            <a:pPr algn="ctr">
+              <a:defRPr sz="1300">
+                <a:solidFill>
+                  <a:srgbClr val="000000"/>
+                </a:solidFill>
+              </a:defRPr>
             </a:pPr>
             <a:r>
-              <a:t>Finding</a:t>
-            </a:r>
-          </a:p>
-          <a:p>
-            <a:pPr>
-              <a:defRPr sz="1100"/>
-            </a:pPr>
+              <a:t>5) Finding</a:t>
+            </a:r>
+            <a:br/>
             <a:r>
               <a:t>Reflector</a:t>
             </a:r>
@@ -3796,15 +3844,20 @@
         </p:nvSpPr>
         <p:spPr>
           <a:xfrm>
-            <a:off x="6675120" y="3794760"/>
-            <a:ext cx="1554480" cy="594360"/>
+            <a:off x="6583680" y="3474720"/>
+            <a:ext cx="1828800" cy="640080"/>
           </a:xfrm>
           <a:prstGeom prst="roundRect">
             <a:avLst/>
           </a:prstGeom>
           <a:solidFill>
-            <a:srgbClr val="FFE6E6"/>
+            <a:srgbClr val="FCE4D6"/>
           </a:solidFill>
+          <a:ln w="15875">
+            <a:solidFill>
+              <a:srgbClr val="464646"/>
+            </a:solidFill>
+          </a:ln>
         </p:spPr>
         <p:style>
           <a:lnRef idx="1">
@@ -3824,19 +3877,19 @@
           <a:bodyPr rtlCol="0" anchor="ctr"/>
           <a:lstStyle/>
           <a:p>
-            <a:pPr>
-              <a:defRPr sz="1100"/>
+            <a:pPr algn="ctr">
+              <a:defRPr sz="1300">
+                <a:solidFill>
+                  <a:srgbClr val="000000"/>
+                </a:solidFill>
+              </a:defRPr>
             </a:pPr>
             <a:r>
-              <a:t>执行失败/编译错</a:t>
-            </a:r>
-          </a:p>
-          <a:p>
-            <a:pPr>
-              <a:defRPr sz="1100"/>
-            </a:pPr>
-            <a:r>
-              <a:t>→ 返工</a:t>
+              <a:t>执行失败/规范问题</a:t>
+            </a:r>
+            <a:br/>
+            <a:r>
+              <a:t>返回上游重生</a:t>
             </a:r>
           </a:p>
         </p:txBody>
@@ -3849,8 +3902,8 @@
         </p:nvSpPr>
         <p:spPr>
           <a:xfrm>
-            <a:off x="8412480" y="3794760"/>
-            <a:ext cx="1737360" cy="594360"/>
+            <a:off x="8686800" y="3474720"/>
+            <a:ext cx="2560320" cy="640080"/>
           </a:xfrm>
           <a:prstGeom prst="roundRect">
             <a:avLst/>
@@ -3858,6 +3911,11 @@
           <a:solidFill>
             <a:srgbClr val="E2EFDA"/>
           </a:solidFill>
+          <a:ln w="15875">
+            <a:solidFill>
+              <a:srgbClr val="464646"/>
+            </a:solidFill>
+          </a:ln>
         </p:spPr>
         <p:style>
           <a:lnRef idx="1">
@@ -3877,40 +3935,45 @@
           <a:bodyPr rtlCol="0" anchor="ctr"/>
           <a:lstStyle/>
           <a:p>
-            <a:pPr>
-              <a:defRPr sz="1100"/>
+            <a:pPr algn="ctr">
+              <a:defRPr sz="1300">
+                <a:solidFill>
+                  <a:srgbClr val="000000"/>
+                </a:solidFill>
+              </a:defRPr>
             </a:pPr>
             <a:r>
               <a:t>确认漏洞</a:t>
             </a:r>
-          </a:p>
-          <a:p>
-            <a:pPr>
-              <a:defRPr sz="1100"/>
-            </a:pPr>
-            <a:r>
-              <a:t>报告并回写 G</a:t>
-            </a:r>
-          </a:p>
-        </p:txBody>
-      </p:sp>
-      <p:sp>
-        <p:nvSpPr>
-          <p:cNvPr id="16" name="Rectangle 15"/>
+            <a:br/>
+            <a:r>
+              <a:t>报告并回写图谱 G</a:t>
+            </a:r>
+          </a:p>
+        </p:txBody>
+      </p:sp>
+      <p:sp>
+        <p:nvSpPr>
+          <p:cNvPr id="16" name="Rounded Rectangle 15"/>
           <p:cNvSpPr/>
           <p:nvPr/>
         </p:nvSpPr>
         <p:spPr>
           <a:xfrm>
-            <a:off x="6309360" y="4663440"/>
-            <a:ext cx="4114800" cy="685800"/>
-          </a:xfrm>
-          <a:prstGeom prst="rect">
+            <a:off x="2377440" y="4572000"/>
+            <a:ext cx="8869680" cy="777240"/>
+          </a:xfrm>
+          <a:prstGeom prst="roundRect">
             <a:avLst/>
           </a:prstGeom>
           <a:solidFill>
             <a:srgbClr val="F2F2F2"/>
           </a:solidFill>
+          <a:ln w="15875">
+            <a:solidFill>
+              <a:srgbClr val="464646"/>
+            </a:solidFill>
+          </a:ln>
         </p:spPr>
         <p:style>
           <a:lnRef idx="1">
@@ -3930,11 +3993,15 @@
           <a:bodyPr rtlCol="0" anchor="ctr"/>
           <a:lstStyle/>
           <a:p>
-            <a:pPr>
-              <a:defRPr sz="1100"/>
+            <a:pPr algn="ctr">
+              <a:defRPr sz="1300">
+                <a:solidFill>
+                  <a:srgbClr val="000000"/>
+                </a:solidFill>
+              </a:defRPr>
             </a:pPr>
             <a:r>
-              <a:t>共享 Working Memory：覆盖率、执行轨迹、违规反馈、修复历史</a:t>
+              <a:t>共享 Working Memory：覆盖率、执行轨迹、违规反馈、修复历史（为下一轮调度提供依据）</a:t>
             </a:r>
           </a:p>
         </p:txBody>
@@ -3946,16 +4013,16 @@
           <p:nvPr/>
         </p:nvCxnSpPr>
         <p:spPr>
-          <a:xfrm flipV="1">
-            <a:off x="2103120" y="1097280"/>
-            <a:ext cx="274320" cy="91440"/>
+          <a:xfrm>
+            <a:off x="2103120" y="1188720"/>
+            <a:ext cx="274320" cy="0"/>
           </a:xfrm>
           <a:prstGeom prst="line">
             <a:avLst/>
           </a:prstGeom>
-          <a:ln w="19050">
+          <a:ln w="20320">
             <a:solidFill>
-              <a:srgbClr val="5A5A5A"/>
+              <a:srgbClr val="464646"/>
             </a:solidFill>
           </a:ln>
         </p:spPr>
@@ -3982,15 +4049,15 @@
         </p:nvCxnSpPr>
         <p:spPr>
           <a:xfrm>
-            <a:off x="2103120" y="1188720"/>
-            <a:ext cx="274320" cy="822960"/>
+            <a:off x="4206240" y="1188720"/>
+            <a:ext cx="274320" cy="0"/>
           </a:xfrm>
           <a:prstGeom prst="line">
             <a:avLst/>
           </a:prstGeom>
-          <a:ln w="19050">
+          <a:ln w="20320">
             <a:solidFill>
-              <a:srgbClr val="5A5A5A"/>
+              <a:srgbClr val="464646"/>
             </a:solidFill>
           </a:ln>
         </p:spPr>
@@ -4017,15 +4084,15 @@
         </p:nvCxnSpPr>
         <p:spPr>
           <a:xfrm>
-            <a:off x="2103120" y="1188720"/>
-            <a:ext cx="274320" cy="1737360"/>
+            <a:off x="6309360" y="1188720"/>
+            <a:ext cx="274320" cy="0"/>
           </a:xfrm>
           <a:prstGeom prst="line">
             <a:avLst/>
           </a:prstGeom>
-          <a:ln w="19050">
+          <a:ln w="20320">
             <a:solidFill>
-              <a:srgbClr val="5A5A5A"/>
+              <a:srgbClr val="464646"/>
             </a:solidFill>
           </a:ln>
         </p:spPr>
@@ -4052,15 +4119,15 @@
         </p:nvCxnSpPr>
         <p:spPr>
           <a:xfrm>
-            <a:off x="4297680" y="1097280"/>
-            <a:ext cx="274320" cy="731520"/>
+            <a:off x="8412480" y="1188720"/>
+            <a:ext cx="274320" cy="0"/>
           </a:xfrm>
           <a:prstGeom prst="line">
             <a:avLst/>
           </a:prstGeom>
-          <a:ln w="19050">
+          <a:ln w="20320">
             <a:solidFill>
-              <a:srgbClr val="5A5A5A"/>
+              <a:srgbClr val="464646"/>
             </a:solidFill>
           </a:ln>
         </p:spPr>
@@ -4087,15 +4154,15 @@
         </p:nvCxnSpPr>
         <p:spPr>
           <a:xfrm>
-            <a:off x="4297680" y="2011680"/>
+            <a:off x="2103120" y="2514600"/>
             <a:ext cx="274320" cy="0"/>
           </a:xfrm>
           <a:prstGeom prst="line">
             <a:avLst/>
           </a:prstGeom>
-          <a:ln w="19050">
+          <a:ln w="20320">
             <a:solidFill>
-              <a:srgbClr val="5A5A5A"/>
+              <a:srgbClr val="464646"/>
             </a:solidFill>
           </a:ln>
         </p:spPr>
@@ -4121,16 +4188,16 @@
           <p:nvPr/>
         </p:nvCxnSpPr>
         <p:spPr>
-          <a:xfrm flipV="1">
-            <a:off x="4297680" y="2194560"/>
-            <a:ext cx="274320" cy="731520"/>
+          <a:xfrm>
+            <a:off x="4206240" y="2514600"/>
+            <a:ext cx="274320" cy="0"/>
           </a:xfrm>
           <a:prstGeom prst="line">
             <a:avLst/>
           </a:prstGeom>
-          <a:ln w="19050">
+          <a:ln w="20320">
             <a:solidFill>
-              <a:srgbClr val="5A5A5A"/>
+              <a:srgbClr val="464646"/>
             </a:solidFill>
           </a:ln>
         </p:spPr>
@@ -4156,16 +4223,16 @@
           <p:nvPr/>
         </p:nvCxnSpPr>
         <p:spPr>
-          <a:xfrm flipV="1">
-            <a:off x="6400800" y="1143000"/>
-            <a:ext cx="2011680" cy="868680"/>
+          <a:xfrm>
+            <a:off x="6309360" y="2514600"/>
+            <a:ext cx="274320" cy="0"/>
           </a:xfrm>
           <a:prstGeom prst="line">
             <a:avLst/>
           </a:prstGeom>
-          <a:ln w="19050">
+          <a:ln w="20320">
             <a:solidFill>
-              <a:srgbClr val="5A5A5A"/>
+              <a:srgbClr val="464646"/>
             </a:solidFill>
           </a:ln>
         </p:spPr>
@@ -4192,15 +4259,15 @@
         </p:nvCxnSpPr>
         <p:spPr>
           <a:xfrm>
-            <a:off x="8229600" y="1143000"/>
-            <a:ext cx="182880" cy="0"/>
+            <a:off x="8412480" y="2514600"/>
+            <a:ext cx="274320" cy="0"/>
           </a:xfrm>
           <a:prstGeom prst="line">
             <a:avLst/>
           </a:prstGeom>
-          <a:ln w="19050">
+          <a:ln w="20320">
             <a:solidFill>
-              <a:srgbClr val="5A5A5A"/>
+              <a:srgbClr val="464646"/>
             </a:solidFill>
           </a:ln>
         </p:spPr>
@@ -4226,16 +4293,16 @@
           <p:nvPr/>
         </p:nvCxnSpPr>
         <p:spPr>
-          <a:xfrm flipH="1">
-            <a:off x="6675120" y="1143000"/>
-            <a:ext cx="3474720" cy="1005840"/>
+          <a:xfrm>
+            <a:off x="9875520" y="2514600"/>
+            <a:ext cx="274320" cy="0"/>
           </a:xfrm>
           <a:prstGeom prst="line">
             <a:avLst/>
           </a:prstGeom>
-          <a:ln w="19050">
+          <a:ln w="20320">
             <a:solidFill>
-              <a:srgbClr val="5A5A5A"/>
+              <a:srgbClr val="464646"/>
             </a:solidFill>
           </a:ln>
         </p:spPr>
@@ -4261,16 +4328,16 @@
           <p:nvPr/>
         </p:nvCxnSpPr>
         <p:spPr>
-          <a:xfrm>
-            <a:off x="8229600" y="2148840"/>
-            <a:ext cx="182880" cy="0"/>
+          <a:xfrm flipH="1">
+            <a:off x="3657600" y="1554480"/>
+            <a:ext cx="5029200" cy="594360"/>
           </a:xfrm>
           <a:prstGeom prst="line">
             <a:avLst/>
           </a:prstGeom>
-          <a:ln w="19050">
+          <a:ln w="20320">
             <a:solidFill>
-              <a:srgbClr val="5A5A5A"/>
+              <a:srgbClr val="464646"/>
             </a:solidFill>
           </a:ln>
         </p:spPr>
@@ -4297,15 +4364,15 @@
         </p:nvCxnSpPr>
         <p:spPr>
           <a:xfrm flipH="1">
-            <a:off x="6675120" y="2148840"/>
-            <a:ext cx="3474720" cy="1005840"/>
+            <a:off x="7498079" y="2880360"/>
+            <a:ext cx="1783081" cy="594360"/>
           </a:xfrm>
           <a:prstGeom prst="line">
             <a:avLst/>
           </a:prstGeom>
-          <a:ln w="19050">
+          <a:ln w="20320">
             <a:solidFill>
-              <a:srgbClr val="5A5A5A"/>
+              <a:srgbClr val="464646"/>
             </a:solidFill>
           </a:ln>
         </p:spPr>
@@ -4331,16 +4398,16 @@
           <p:nvPr/>
         </p:nvCxnSpPr>
         <p:spPr>
-          <a:xfrm>
-            <a:off x="8229600" y="3154680"/>
-            <a:ext cx="182880" cy="0"/>
+          <a:xfrm flipH="1">
+            <a:off x="9966960" y="2880360"/>
+            <a:ext cx="731520" cy="594360"/>
           </a:xfrm>
           <a:prstGeom prst="line">
             <a:avLst/>
           </a:prstGeom>
-          <a:ln w="19050">
+          <a:ln w="20320">
             <a:solidFill>
-              <a:srgbClr val="5A5A5A"/>
+              <a:srgbClr val="464646"/>
             </a:solidFill>
           </a:ln>
         </p:spPr>
@@ -4366,16 +4433,16 @@
           <p:nvPr/>
         </p:nvCxnSpPr>
         <p:spPr>
-          <a:xfrm>
-            <a:off x="7452360" y="3474720"/>
-            <a:ext cx="0" cy="320040"/>
+          <a:xfrm flipV="1">
+            <a:off x="7498079" y="2880360"/>
+            <a:ext cx="0" cy="594360"/>
           </a:xfrm>
           <a:prstGeom prst="line">
             <a:avLst/>
           </a:prstGeom>
-          <a:ln w="19050">
+          <a:ln w="20320">
             <a:solidFill>
-              <a:srgbClr val="5A5A5A"/>
+              <a:srgbClr val="464646"/>
             </a:solidFill>
           </a:ln>
         </p:spPr>
@@ -4401,16 +4468,16 @@
           <p:nvPr/>
         </p:nvCxnSpPr>
         <p:spPr>
-          <a:xfrm>
-            <a:off x="9281160" y="3474720"/>
-            <a:ext cx="0" cy="320040"/>
+          <a:xfrm flipV="1">
+            <a:off x="9966960" y="1554480"/>
+            <a:ext cx="0" cy="1920240"/>
           </a:xfrm>
           <a:prstGeom prst="line">
             <a:avLst/>
           </a:prstGeom>
-          <a:ln w="19050">
+          <a:ln w="20320">
             <a:solidFill>
-              <a:srgbClr val="5A5A5A"/>
+              <a:srgbClr val="464646"/>
             </a:solidFill>
           </a:ln>
         </p:spPr>
@@ -4436,16 +4503,16 @@
           <p:nvPr/>
         </p:nvCxnSpPr>
         <p:spPr>
-          <a:xfrm flipV="1">
-            <a:off x="7452360" y="2468880"/>
-            <a:ext cx="1828800" cy="1325880"/>
+          <a:xfrm>
+            <a:off x="9281160" y="2880360"/>
+            <a:ext cx="0" cy="1691640"/>
           </a:xfrm>
           <a:prstGeom prst="line">
             <a:avLst/>
           </a:prstGeom>
-          <a:ln w="19050">
+          <a:ln w="20320">
             <a:solidFill>
-              <a:srgbClr val="5A5A5A"/>
+              <a:srgbClr val="464646"/>
             </a:solidFill>
           </a:ln>
         </p:spPr>
@@ -4471,16 +4538,16 @@
           <p:nvPr/>
         </p:nvCxnSpPr>
         <p:spPr>
-          <a:xfrm flipH="1" flipV="1">
-            <a:off x="7452360" y="2468880"/>
-            <a:ext cx="1828800" cy="1325880"/>
+          <a:xfrm>
+            <a:off x="10698480" y="2880360"/>
+            <a:ext cx="0" cy="1691640"/>
           </a:xfrm>
           <a:prstGeom prst="line">
             <a:avLst/>
           </a:prstGeom>
-          <a:ln w="19050">
+          <a:ln w="20320">
             <a:solidFill>
-              <a:srgbClr val="5A5A5A"/>
+              <a:srgbClr val="464646"/>
             </a:solidFill>
           </a:ln>
         </p:spPr>
@@ -4507,15 +4574,15 @@
         </p:nvCxnSpPr>
         <p:spPr>
           <a:xfrm flipH="1" flipV="1">
-            <a:off x="5486400" y="2560320"/>
-            <a:ext cx="3794760" cy="1828800"/>
+            <a:off x="3291840" y="2880360"/>
+            <a:ext cx="2651760" cy="1691640"/>
           </a:xfrm>
           <a:prstGeom prst="line">
             <a:avLst/>
           </a:prstGeom>
-          <a:ln w="19050">
+          <a:ln w="20320">
             <a:solidFill>
-              <a:srgbClr val="5A5A5A"/>
+              <a:srgbClr val="464646"/>
             </a:solidFill>
           </a:ln>
         </p:spPr>
@@ -4541,16 +4608,16 @@
           <p:nvPr/>
         </p:nvCxnSpPr>
         <p:spPr>
-          <a:xfrm>
-            <a:off x="7452360" y="3474720"/>
-            <a:ext cx="0" cy="1188720"/>
+          <a:xfrm flipH="1" flipV="1">
+            <a:off x="5394960" y="2880360"/>
+            <a:ext cx="1737360" cy="1691640"/>
           </a:xfrm>
           <a:prstGeom prst="line">
             <a:avLst/>
           </a:prstGeom>
-          <a:ln w="19050">
+          <a:ln w="20320">
             <a:solidFill>
-              <a:srgbClr val="5A5A5A"/>
+              <a:srgbClr val="464646"/>
             </a:solidFill>
           </a:ln>
         </p:spPr>
@@ -4569,121 +4636,16 @@
           </a:fontRef>
         </p:style>
       </p:cxnSp>
-      <p:cxnSp>
-        <p:nvCxnSpPr>
-          <p:cNvPr id="35" name="Connector 34"/>
-          <p:cNvCxnSpPr/>
-          <p:nvPr/>
-        </p:nvCxnSpPr>
-        <p:spPr>
-          <a:xfrm>
-            <a:off x="9281160" y="3474720"/>
-            <a:ext cx="0" cy="1188720"/>
-          </a:xfrm>
-          <a:prstGeom prst="line">
-            <a:avLst/>
-          </a:prstGeom>
-          <a:ln w="19050">
-            <a:solidFill>
-              <a:srgbClr val="5A5A5A"/>
-            </a:solidFill>
-          </a:ln>
-        </p:spPr>
-        <p:style>
-          <a:lnRef idx="2">
-            <a:schemeClr val="accent1"/>
-          </a:lnRef>
-          <a:fillRef idx="0">
-            <a:schemeClr val="accent1"/>
-          </a:fillRef>
-          <a:effectRef idx="1">
-            <a:schemeClr val="accent1"/>
-          </a:effectRef>
-          <a:fontRef idx="minor">
-            <a:schemeClr val="tx1"/>
-          </a:fontRef>
-        </p:style>
-      </p:cxnSp>
-      <p:cxnSp>
-        <p:nvCxnSpPr>
-          <p:cNvPr id="36" name="Connector 35"/>
-          <p:cNvCxnSpPr/>
-          <p:nvPr/>
-        </p:nvCxnSpPr>
-        <p:spPr>
-          <a:xfrm flipH="1" flipV="1">
-            <a:off x="7452360" y="2468880"/>
-            <a:ext cx="1691640" cy="2194560"/>
-          </a:xfrm>
-          <a:prstGeom prst="line">
-            <a:avLst/>
-          </a:prstGeom>
-          <a:ln w="19050">
-            <a:solidFill>
-              <a:srgbClr val="5A5A5A"/>
-            </a:solidFill>
-          </a:ln>
-        </p:spPr>
-        <p:style>
-          <a:lnRef idx="2">
-            <a:schemeClr val="accent1"/>
-          </a:lnRef>
-          <a:fillRef idx="0">
-            <a:schemeClr val="accent1"/>
-          </a:fillRef>
-          <a:effectRef idx="1">
-            <a:schemeClr val="accent1"/>
-          </a:effectRef>
-          <a:fontRef idx="minor">
-            <a:schemeClr val="tx1"/>
-          </a:fontRef>
-        </p:style>
-      </p:cxnSp>
-      <p:cxnSp>
-        <p:nvCxnSpPr>
-          <p:cNvPr id="37" name="Connector 36"/>
-          <p:cNvCxnSpPr/>
-          <p:nvPr/>
-        </p:nvCxnSpPr>
-        <p:spPr>
-          <a:xfrm flipH="1" flipV="1">
-            <a:off x="9281160" y="2468880"/>
-            <a:ext cx="411480" cy="2194560"/>
-          </a:xfrm>
-          <a:prstGeom prst="line">
-            <a:avLst/>
-          </a:prstGeom>
-          <a:ln w="19050">
-            <a:solidFill>
-              <a:srgbClr val="5A5A5A"/>
-            </a:solidFill>
-          </a:ln>
-        </p:spPr>
-        <p:style>
-          <a:lnRef idx="2">
-            <a:schemeClr val="accent1"/>
-          </a:lnRef>
-          <a:fillRef idx="0">
-            <a:schemeClr val="accent1"/>
-          </a:fillRef>
-          <a:effectRef idx="1">
-            <a:schemeClr val="accent1"/>
-          </a:effectRef>
-          <a:fontRef idx="minor">
-            <a:schemeClr val="tx1"/>
-          </a:fontRef>
-        </p:style>
-      </p:cxnSp>
-      <p:sp>
-        <p:nvSpPr>
-          <p:cNvPr id="38" name="TextBox 37"/>
+      <p:sp>
+        <p:nvSpPr>
+          <p:cNvPr id="35" name="TextBox 34"/>
           <p:cNvSpPr txBox="1"/>
           <p:nvPr/>
         </p:nvSpPr>
         <p:spPr>
           <a:xfrm>
-            <a:off x="274320" y="5394960"/>
-            <a:ext cx="11612880" cy="548640"/>
+            <a:off x="365760" y="4251960"/>
+            <a:ext cx="1828800" cy="274320"/>
           </a:xfrm>
           <a:prstGeom prst="rect">
             <a:avLst/>
@@ -4697,14 +4659,73 @@
           <a:lstStyle/>
           <a:p>
             <a:pPr>
-              <a:defRPr sz="1200">
+              <a:defRPr sz="1200" b="1">
                 <a:solidFill>
-                  <a:srgbClr val="3C3C3C"/>
+                  <a:srgbClr val="000000"/>
                 </a:solidFill>
               </a:defRPr>
             </a:pPr>
             <a:r>
-              <a:t>迭代策略：若执行失败→重建 Harness；若规范有问题→重生 Specification；若确认漏洞→输出报告并将新知识增量写入图谱 G。</a:t>
+              <a:t>说明：</a:t>
+            </a:r>
+          </a:p>
+        </p:txBody>
+      </p:sp>
+      <p:sp>
+        <p:nvSpPr>
+          <p:cNvPr id="36" name="TextBox 35"/>
+          <p:cNvSpPr txBox="1"/>
+          <p:nvPr/>
+        </p:nvSpPr>
+        <p:spPr>
+          <a:xfrm>
+            <a:off x="365760" y="4526280"/>
+            <a:ext cx="1828800" cy="914400"/>
+          </a:xfrm>
+          <a:prstGeom prst="rect">
+            <a:avLst/>
+          </a:prstGeom>
+          <a:noFill/>
+        </p:spPr>
+        <p:txBody>
+          <a:bodyPr wrap="none">
+            <a:spAutoFit/>
+          </a:bodyPr>
+          <a:lstStyle/>
+          <a:p>
+            <a:pPr>
+              <a:defRPr sz="1000">
+                <a:solidFill>
+                  <a:srgbClr val="000000"/>
+                </a:solidFill>
+              </a:defRPr>
+            </a:pPr>
+            <a:r>
+              <a:t>直线箭头：明确单向流向</a:t>
+            </a:r>
+          </a:p>
+          <a:p>
+            <a:pPr>
+              <a:defRPr sz="1000">
+                <a:solidFill>
+                  <a:srgbClr val="000000"/>
+                </a:solidFill>
+              </a:defRPr>
+            </a:pPr>
+            <a:r>
+              <a:t>主流程按 1→5 顺序执行</a:t>
+            </a:r>
+          </a:p>
+          <a:p>
+            <a:pPr>
+              <a:defRPr sz="1000">
+                <a:solidFill>
+                  <a:srgbClr val="000000"/>
+                </a:solidFill>
+              </a:defRPr>
+            </a:pPr>
+            <a:r>
+              <a:t>返工仅回到上游节点</a:t>
             </a:r>
           </a:p>
         </p:txBody>

</xml_diff>